<commit_message>
fix: summary deck self-check -- CVE citation count, release density source, OS package rows
Co-Authored-By: Claude Fable 5.1 <noreply@anthropic.com>
Claude-Session: https://claude.ai/code/session_01JM7zyy7DyMdzKZZxhHrRfK
</commit_message>
<xml_diff>
--- a/out/analysis/dnssec_software_summary.pptx
+++ b/out/analysis/dnssec_software_summary.pptx
@@ -3551,7 +3551,7 @@
                 </a:solidFill>
                 <a:latin typeface="Segoe UI"/>
               </a:rPr>
-              <a:t>the first Ubuntu LTS (16.04 to 24.04) and Debian (11 to 13) release carrying each version, from Launchpad and the Debian tracker: the path by which most operators actually receive a new default.</a:t>
+              <a:t>the first Ubuntu LTS (16.04 to 24.04) and Debian (9 to 13) release carrying each version, from Launchpad and sources.debian.org: the path by which most operators actually receive a new default. The new-signings test is run around each OS release as well as around the upstream one.</a:t>
             </a:r>
           </a:p>
         </p:txBody>
@@ -5018,7 +5018,7 @@
                 </a:solidFill>
                 <a:latin typeface="Segoe UI"/>
               </a:rPr>
-              <a:t>Defaults sit closer to take-off than RFCs do, but no event study or release scan finds a release month that moves the curve: after detrending, the smallest circular-shift p across the eight projects is 0.11. 97% of months contain some DNS release, so 'a release came just before' is always true and never evidence.</a:t>
+              <a:t>Defaults sit closer to take-off than RFCs do, but no event study or release scan finds a release month that moves the curve: after detrending, the smallest circular-shift p across the eight projects is 0.11. 97% of months in the release-scan span contain a stable release of one of the eight, so 'a release came just before' is always true and never evidence. Where defaults do show is in what newly signed zones choose, after the OS release that carries them (slide 5).</a:t>
             </a:r>
           </a:p>
           <a:p>
@@ -5774,7 +5774,7 @@
                 </a:solidFill>
                 <a:latin typeface="Segoe UI"/>
               </a:rPr>
-              <a:t>A CVE is attached to an RFC by the mechanism its description names, not by citing the RFC; only CVE-2023-50868 (NSEC3) and CVE-2013-4854 (RFC 5011) name their RFC in the text.</a:t>
+              <a:t>A CVE is attached to an RFC by the mechanism its description names, not by citing the RFC: 6 of the 97 DNSSEC CVEs cite any RFC in their text, and only 2 cite one of the RFCs studied here (CVE-2013-4854 -&gt; RFC 5011; CVE-2023-50868 -&gt; RFC 5155, 9276).</a:t>
             </a:r>
           </a:p>
           <a:p>
@@ -5950,10 +5950,10 @@
                 <a:tableStyleId>{5C22544A-7EE6-4342-B048-85BDC9FD1C3A}</a:tableStyleId>
               </a:tblPr>
               <a:tblGrid>
-                <a:gridCol w="2011680"/>
-                <a:gridCol w="1371600"/>
-                <a:gridCol w="3291840"/>
-                <a:gridCol w="4572000"/>
+                <a:gridCol w="1828800"/>
+                <a:gridCol w="1280160"/>
+                <a:gridCol w="4023360"/>
+                <a:gridCol w="4114800"/>
               </a:tblGrid>
               <a:tr h="274320">
                 <a:tc>
@@ -6181,7 +6181,7 @@
                             <a:srgbClr val="0B0B0B"/>
                           </a:solidFill>
                         </a:rPr>
-                        <a:t>signer default (2016) + operator rollovers</a:t>
+                        <a:t>signer defaults reach new zones via Debian 9 (2017); majority by operator rollovers</a:t>
                       </a:r>
                     </a:p>
                   </a:txBody>

</xml_diff>

<commit_message>
fix: add a rank-based test -- the medians are right but fragile at n=16
The three medians reproduce exactly from the panel parquet (CVE 4.0 = the
11th of 21; RFC 4.2 = the mean of 3.6 and 4.8; other months 3.9). But the
RFC median falls in a 1.2-wide gap between its two middle values, so it
would swing on one point. The comparison now also runs on ranks, which use
every observation: p = 0.72 CVE vs RFC, 0.47 and 0.87 against ordinary
months. Same conclusion, not resting on the middle value.

Co-Authored-By: Claude Opus 5 (1M context) <noreply@anthropic.com>
Claude-Session: https://claude.ai/code/session_01JM7zyy7DyMdzKZZxhHrRfK
</commit_message>
<xml_diff>
--- a/out/analysis/dnssec_software_summary.pptx
+++ b/out/analysis/dnssec_software_summary.pptx
@@ -7344,7 +7344,23 @@
                 </a:solidFill>
                 <a:latin typeface="Segoe UI"/>
               </a:rPr>
-              <a:t>Take every month in which a DNSSEC CVE was patched (21 months; 39 CVEs, several sharing a fix month) and every month in which a DNSSEC RFC was published (16 months inside the reverse series). The adoption rate over that month and the three after it has the same distribution in both groups and in ordinary months: medians 4.0, 4.2 and 3.9 thousandths of a point per month; permutation p = 0.93.</a:t>
+              <a:t>Take every month in which a DNSSEC CVE was patched (21 months; 39 CVEs, several sharing a fix month) and every month in which a DNSSEC RFC was published (16 months inside the reverse series). The adoption rate over that month and the three after it has the same distribution in all three groups. Medians 4.0, 4.2 and 3.9 thousandths of a point per month, on 21, 16 and 140 months.</a:t>
+            </a:r>
+          </a:p>
+          <a:p>
+            <a:pPr>
+              <a:spcAft>
+                <a:spcPts val="600"/>
+              </a:spcAft>
+            </a:pPr>
+            <a:r>
+              <a:rPr sz="1100" b="0">
+                <a:solidFill>
+                  <a:srgbClr val="0B0B0B"/>
+                </a:solidFill>
+                <a:latin typeface="Segoe UI"/>
+              </a:rPr>
+              <a:t>The medians are a fragile summary at this sample size -- with 16 RFC months the median falls in a gap between the 8th and 9th values -- so the comparison is also run on ranks, which use every observation. Neither separates the groups: median permutation p = 0.93, rank permutation p = 0.72 for CVE against RFC, 0.47 and 0.87 for each against ordinary months.</a:t>
             </a:r>
           </a:p>
           <a:p>

</xml_diff>